<commit_message>
[fix] ppt & docx
</commit_message>
<xml_diff>
--- a/팀_RLCC_최종 발표.pptx
+++ b/팀_RLCC_최종 발표.pptx
@@ -9562,7 +9562,7 @@
                 <a:ea typeface="배달의민족 주아" panose="02020603020101020101" pitchFamily="18" charset="-127"/>
                 <a:cs typeface="Calibri" pitchFamily="34" charset="-120"/>
               </a:rPr>
-              <a:t>포만감 0 → 아사 (즉시 사망)</a:t>
+              <a:t>포만감 0 -&gt; 아사 (즉시 사망)</a:t>
             </a:r>
             <a:endParaRPr lang="en-US" sz="1400" dirty="0">
               <a:latin typeface="배달의민족 주아" panose="02020603020101020101" pitchFamily="18" charset="-127"/>
@@ -9584,7 +9584,29 @@
                 <a:ea typeface="배달의민족 주아" panose="02020603020101020101" pitchFamily="18" charset="-127"/>
                 <a:cs typeface="Calibri" pitchFamily="34" charset="-120"/>
               </a:rPr>
-              <a:t>청결도 0 → 병사 (즉시 사망)</a:t>
+              <a:t>청결도 0 -&gt; </a:t>
+            </a:r>
+            <a:r>
+              <a:rPr lang="en-US" sz="1400" dirty="0" err="1">
+                <a:solidFill>
+                  <a:srgbClr val="1A2B3C"/>
+                </a:solidFill>
+                <a:latin typeface="배달의민족 주아" panose="02020603020101020101" pitchFamily="18" charset="-127"/>
+                <a:ea typeface="배달의민족 주아" panose="02020603020101020101" pitchFamily="18" charset="-127"/>
+                <a:cs typeface="Calibri" pitchFamily="34" charset="-120"/>
+              </a:rPr>
+              <a:t>병사</a:t>
+            </a:r>
+            <a:r>
+              <a:rPr lang="en-US" sz="1400" dirty="0">
+                <a:solidFill>
+                  <a:srgbClr val="1A2B3C"/>
+                </a:solidFill>
+                <a:latin typeface="배달의민족 주아" panose="02020603020101020101" pitchFamily="18" charset="-127"/>
+                <a:ea typeface="배달의민족 주아" panose="02020603020101020101" pitchFamily="18" charset="-127"/>
+                <a:cs typeface="Calibri" pitchFamily="34" charset="-120"/>
+              </a:rPr>
+              <a:t> (즉시 사망)</a:t>
             </a:r>
             <a:endParaRPr lang="en-US" sz="1400" dirty="0">
               <a:latin typeface="배달의민족 주아" panose="02020603020101020101" pitchFamily="18" charset="-127"/>
@@ -9606,7 +9628,7 @@
                 <a:ea typeface="배달의민족 주아" panose="02020603020101020101" pitchFamily="18" charset="-127"/>
                 <a:cs typeface="Calibri" pitchFamily="34" charset="-120"/>
               </a:rPr>
-              <a:t>스트레스 90+ → 도주 엔딩 발동</a:t>
+              <a:t>스트레스 90+도주 엔딩 발동</a:t>
             </a:r>
             <a:endParaRPr lang="en-US" sz="1400" dirty="0">
               <a:latin typeface="배달의민족 주아" panose="02020603020101020101" pitchFamily="18" charset="-127"/>
@@ -9995,7 +10017,7 @@
           <p:nvPr>
             <p:extLst>
               <p:ext uri="{D42A27DB-BD31-4B8C-83A1-F6EECF244321}">
-                <p14:modId xmlns:p14="http://schemas.microsoft.com/office/powerpoint/2010/main" val="3537366624"/>
+                <p14:modId xmlns:p14="http://schemas.microsoft.com/office/powerpoint/2010/main" val="1262578005"/>
               </p:ext>
             </p:extLst>
           </p:nvPr>
@@ -10385,6 +10407,17 @@
                         <a:buNone/>
                       </a:pPr>
                       <a:r>
+                        <a:rPr lang="en-US" sz="1400" b="0" dirty="0" err="1">
+                          <a:solidFill>
+                            <a:srgbClr val="1A2B3C"/>
+                          </a:solidFill>
+                          <a:latin typeface="배달의민족 주아" panose="02020603020101020101" pitchFamily="18" charset="-127"/>
+                          <a:ea typeface="배달의민족 주아" panose="02020603020101020101" pitchFamily="18" charset="-127"/>
+                          <a:cs typeface="Calibri" pitchFamily="34" charset="-120"/>
+                        </a:rPr>
+                        <a:t>포만감</a:t>
+                      </a:r>
+                      <a:r>
                         <a:rPr lang="en-US" sz="1400" b="0" dirty="0">
                           <a:solidFill>
                             <a:srgbClr val="1A2B3C"/>
@@ -10393,7 +10426,7 @@
                           <a:ea typeface="배달의민족 주아" panose="02020603020101020101" pitchFamily="18" charset="-127"/>
                           <a:cs typeface="Calibri" pitchFamily="34" charset="-120"/>
                         </a:rPr>
-                        <a:t>포만감 = 0</a:t>
+                        <a:t> 0</a:t>
                       </a:r>
                       <a:endParaRPr lang="en-US" sz="1400" b="0" dirty="0">
                         <a:latin typeface="배달의민족 주아" panose="02020603020101020101" pitchFamily="18" charset="-127"/>
@@ -10569,6 +10602,17 @@
                         <a:buNone/>
                       </a:pPr>
                       <a:r>
+                        <a:rPr lang="en-US" sz="1400" b="0" dirty="0" err="1">
+                          <a:solidFill>
+                            <a:srgbClr val="1A2B3C"/>
+                          </a:solidFill>
+                          <a:latin typeface="배달의민족 주아" panose="02020603020101020101" pitchFamily="18" charset="-127"/>
+                          <a:ea typeface="배달의민족 주아" panose="02020603020101020101" pitchFamily="18" charset="-127"/>
+                          <a:cs typeface="Calibri" pitchFamily="34" charset="-120"/>
+                        </a:rPr>
+                        <a:t>청결도</a:t>
+                      </a:r>
+                      <a:r>
                         <a:rPr lang="en-US" sz="1400" b="0" dirty="0">
                           <a:solidFill>
                             <a:srgbClr val="1A2B3C"/>
@@ -10577,7 +10621,7 @@
                           <a:ea typeface="배달의민족 주아" panose="02020603020101020101" pitchFamily="18" charset="-127"/>
                           <a:cs typeface="Calibri" pitchFamily="34" charset="-120"/>
                         </a:rPr>
-                        <a:t>청결도 = 0</a:t>
+                        <a:t> 0</a:t>
                       </a:r>
                       <a:endParaRPr lang="en-US" sz="1400" b="0" dirty="0">
                         <a:latin typeface="배달의민족 주아" panose="02020603020101020101" pitchFamily="18" charset="-127"/>
@@ -10753,6 +10797,17 @@
                         <a:buNone/>
                       </a:pPr>
                       <a:r>
+                        <a:rPr lang="en-US" sz="1400" b="0" dirty="0" err="1">
+                          <a:solidFill>
+                            <a:srgbClr val="1A2B3C"/>
+                          </a:solidFill>
+                          <a:latin typeface="배달의민족 주아" panose="02020603020101020101" pitchFamily="18" charset="-127"/>
+                          <a:ea typeface="배달의민족 주아" panose="02020603020101020101" pitchFamily="18" charset="-127"/>
+                          <a:cs typeface="Calibri" pitchFamily="34" charset="-120"/>
+                        </a:rPr>
+                        <a:t>스트레스</a:t>
+                      </a:r>
+                      <a:r>
                         <a:rPr lang="en-US" sz="1400" b="0" dirty="0">
                           <a:solidFill>
                             <a:srgbClr val="1A2B3C"/>
@@ -10761,7 +10816,7 @@
                           <a:ea typeface="배달의민족 주아" panose="02020603020101020101" pitchFamily="18" charset="-127"/>
                           <a:cs typeface="Calibri" pitchFamily="34" charset="-120"/>
                         </a:rPr>
-                        <a:t>스트레스 ≥ 90</a:t>
+                        <a:t> 90</a:t>
                       </a:r>
                       <a:endParaRPr lang="en-US" sz="1400" b="0" dirty="0">
                         <a:latin typeface="배달의민족 주아" panose="02020603020101020101" pitchFamily="18" charset="-127"/>
@@ -10945,7 +11000,29 @@
                           <a:ea typeface="배달의민족 주아" panose="02020603020101020101" pitchFamily="18" charset="-127"/>
                           <a:cs typeface="Calibri" pitchFamily="34" charset="-120"/>
                         </a:rPr>
-                        <a:t>8주 클리어, 만족도 ≤ 35</a:t>
+                        <a:t>8주 클리어, </a:t>
+                      </a:r>
+                      <a:r>
+                        <a:rPr lang="en-US" sz="1400" b="0" dirty="0" err="1">
+                          <a:solidFill>
+                            <a:srgbClr val="1A2B3C"/>
+                          </a:solidFill>
+                          <a:latin typeface="배달의민족 주아" panose="02020603020101020101" pitchFamily="18" charset="-127"/>
+                          <a:ea typeface="배달의민족 주아" panose="02020603020101020101" pitchFamily="18" charset="-127"/>
+                          <a:cs typeface="Calibri" pitchFamily="34" charset="-120"/>
+                        </a:rPr>
+                        <a:t>만족도</a:t>
+                      </a:r>
+                      <a:r>
+                        <a:rPr lang="en-US" sz="1400" b="0" dirty="0">
+                          <a:solidFill>
+                            <a:srgbClr val="1A2B3C"/>
+                          </a:solidFill>
+                          <a:latin typeface="배달의민족 주아" panose="02020603020101020101" pitchFamily="18" charset="-127"/>
+                          <a:ea typeface="배달의민족 주아" panose="02020603020101020101" pitchFamily="18" charset="-127"/>
+                          <a:cs typeface="Calibri" pitchFamily="34" charset="-120"/>
+                        </a:rPr>
+                        <a:t> 35</a:t>
                       </a:r>
                       <a:endParaRPr lang="en-US" sz="1400" b="0" dirty="0">
                         <a:latin typeface="배달의민족 주아" panose="02020603020101020101" pitchFamily="18" charset="-127"/>
@@ -11520,6 +11597,17 @@
                         <a:buNone/>
                       </a:pPr>
                       <a:r>
+                        <a:rPr lang="en-US" sz="1400" b="0" dirty="0" err="1">
+                          <a:solidFill>
+                            <a:srgbClr val="1A2B3C"/>
+                          </a:solidFill>
+                          <a:latin typeface="배달의민족 주아" panose="02020603020101020101" pitchFamily="18" charset="-127"/>
+                          <a:ea typeface="배달의민족 주아" panose="02020603020101020101" pitchFamily="18" charset="-127"/>
+                          <a:cs typeface="Calibri" pitchFamily="34" charset="-120"/>
+                        </a:rPr>
+                        <a:t>만족도</a:t>
+                      </a:r>
+                      <a:r>
                         <a:rPr lang="en-US" sz="1400" b="0" dirty="0">
                           <a:solidFill>
                             <a:srgbClr val="1A2B3C"/>
@@ -11528,7 +11616,7 @@
                           <a:ea typeface="배달의민족 주아" panose="02020603020101020101" pitchFamily="18" charset="-127"/>
                           <a:cs typeface="Calibri" pitchFamily="34" charset="-120"/>
                         </a:rPr>
-                        <a:t>만족도 ≥ 76</a:t>
+                        <a:t> 76</a:t>
                       </a:r>
                       <a:endParaRPr lang="en-US" sz="1400" b="0" dirty="0">
                         <a:latin typeface="배달의민족 주아" panose="02020603020101020101" pitchFamily="18" charset="-127"/>
@@ -11917,7 +12005,29 @@
                           <a:ea typeface="배달의민족 주아" panose="02020603020101020101" pitchFamily="18" charset="-127"/>
                           <a:cs typeface="Calibri" pitchFamily="34" charset="-120"/>
                         </a:rPr>
-                        <a:t>포만감 100 + 만족도 ≥ 85</a:t>
+                        <a:t>포만감 100 + </a:t>
+                      </a:r>
+                      <a:r>
+                        <a:rPr lang="en-US" sz="1400" b="0" dirty="0" err="1">
+                          <a:solidFill>
+                            <a:srgbClr val="1A2B3C"/>
+                          </a:solidFill>
+                          <a:latin typeface="배달의민족 주아" panose="02020603020101020101" pitchFamily="18" charset="-127"/>
+                          <a:ea typeface="배달의민족 주아" panose="02020603020101020101" pitchFamily="18" charset="-127"/>
+                          <a:cs typeface="Calibri" pitchFamily="34" charset="-120"/>
+                        </a:rPr>
+                        <a:t>만족도</a:t>
+                      </a:r>
+                      <a:r>
+                        <a:rPr lang="en-US" sz="1400" b="0" dirty="0">
+                          <a:solidFill>
+                            <a:srgbClr val="1A2B3C"/>
+                          </a:solidFill>
+                          <a:latin typeface="배달의민족 주아" panose="02020603020101020101" pitchFamily="18" charset="-127"/>
+                          <a:ea typeface="배달의민족 주아" panose="02020603020101020101" pitchFamily="18" charset="-127"/>
+                          <a:cs typeface="Calibri" pitchFamily="34" charset="-120"/>
+                        </a:rPr>
+                        <a:t> 85</a:t>
                       </a:r>
                       <a:endParaRPr lang="en-US" sz="1400" b="0" dirty="0">
                         <a:latin typeface="배달의민족 주아" panose="02020603020101020101" pitchFamily="18" charset="-127"/>
@@ -12101,7 +12211,29 @@
                           <a:ea typeface="배달의민족 주아" panose="02020603020101020101" pitchFamily="18" charset="-127"/>
                           <a:cs typeface="Calibri" pitchFamily="34" charset="-120"/>
                         </a:rPr>
-                        <a:t>훈련도 100 + 만족도 ≥ 85</a:t>
+                        <a:t>훈련도 100 + </a:t>
+                      </a:r>
+                      <a:r>
+                        <a:rPr lang="en-US" sz="1400" b="0" dirty="0" err="1">
+                          <a:solidFill>
+                            <a:srgbClr val="1A2B3C"/>
+                          </a:solidFill>
+                          <a:latin typeface="배달의민족 주아" panose="02020603020101020101" pitchFamily="18" charset="-127"/>
+                          <a:ea typeface="배달의민족 주아" panose="02020603020101020101" pitchFamily="18" charset="-127"/>
+                          <a:cs typeface="Calibri" pitchFamily="34" charset="-120"/>
+                        </a:rPr>
+                        <a:t>만족도</a:t>
+                      </a:r>
+                      <a:r>
+                        <a:rPr lang="en-US" sz="1400" b="0" dirty="0">
+                          <a:solidFill>
+                            <a:srgbClr val="1A2B3C"/>
+                          </a:solidFill>
+                          <a:latin typeface="배달의민족 주아" panose="02020603020101020101" pitchFamily="18" charset="-127"/>
+                          <a:ea typeface="배달의민족 주아" panose="02020603020101020101" pitchFamily="18" charset="-127"/>
+                          <a:cs typeface="Calibri" pitchFamily="34" charset="-120"/>
+                        </a:rPr>
+                        <a:t> 85</a:t>
                       </a:r>
                       <a:endParaRPr lang="en-US" sz="1400" b="0" dirty="0">
                         <a:latin typeface="배달의민족 주아" panose="02020603020101020101" pitchFamily="18" charset="-127"/>
@@ -12285,7 +12417,29 @@
                           <a:ea typeface="배달의민족 주아" panose="02020603020101020101" pitchFamily="18" charset="-127"/>
                           <a:cs typeface="Calibri" pitchFamily="34" charset="-120"/>
                         </a:rPr>
-                        <a:t>청결도 100 + 만족도 ≥ 85</a:t>
+                        <a:t>청결도 100 + </a:t>
+                      </a:r>
+                      <a:r>
+                        <a:rPr lang="en-US" sz="1400" b="0" dirty="0" err="1">
+                          <a:solidFill>
+                            <a:srgbClr val="1A2B3C"/>
+                          </a:solidFill>
+                          <a:latin typeface="배달의민족 주아" panose="02020603020101020101" pitchFamily="18" charset="-127"/>
+                          <a:ea typeface="배달의민족 주아" panose="02020603020101020101" pitchFamily="18" charset="-127"/>
+                          <a:cs typeface="Calibri" pitchFamily="34" charset="-120"/>
+                        </a:rPr>
+                        <a:t>만족도</a:t>
+                      </a:r>
+                      <a:r>
+                        <a:rPr lang="en-US" sz="1400" b="0" dirty="0">
+                          <a:solidFill>
+                            <a:srgbClr val="1A2B3C"/>
+                          </a:solidFill>
+                          <a:latin typeface="배달의민족 주아" panose="02020603020101020101" pitchFamily="18" charset="-127"/>
+                          <a:ea typeface="배달의민족 주아" panose="02020603020101020101" pitchFamily="18" charset="-127"/>
+                          <a:cs typeface="Calibri" pitchFamily="34" charset="-120"/>
+                        </a:rPr>
+                        <a:t> 85</a:t>
                       </a:r>
                       <a:endParaRPr lang="en-US" sz="1400" b="0" dirty="0">
                         <a:latin typeface="배달의민족 주아" panose="02020603020101020101" pitchFamily="18" charset="-127"/>

</xml_diff>